<commit_message>
Am modificat dupa sugestii primite la demo.Mai ramane doar sa modific documentatiile.
</commit_message>
<xml_diff>
--- a/Documentations/The-Inventory.pptx
+++ b/Documentations/The-Inventory.pptx
@@ -5,7 +5,7 @@
     <p:sldMasterId id="2147483648" r:id="rId1"/>
   </p:sldMasterIdLst>
   <p:notesMasterIdLst>
-    <p:notesMasterId r:id="rId10"/>
+    <p:notesMasterId r:id="rId11"/>
   </p:notesMasterIdLst>
   <p:sldIdLst>
     <p:sldId id="256" r:id="rId2"/>
@@ -15,7 +15,8 @@
     <p:sldId id="259" r:id="rId6"/>
     <p:sldId id="260" r:id="rId7"/>
     <p:sldId id="264" r:id="rId8"/>
-    <p:sldId id="261" r:id="rId9"/>
+    <p:sldId id="265" r:id="rId9"/>
+    <p:sldId id="261" r:id="rId10"/>
   </p:sldIdLst>
   <p:sldSz cx="9144000" cy="5143500" type="screen16x9"/>
   <p:notesSz cx="5143500" cy="9144000"/>
@@ -813,7 +814,7 @@
           <a:p>
             <a:fld id="{F7021451-1387-4CA6-816F-3879F97B5CBC}" type="slidenum">
               <a:rPr lang="en-US"/>
-              <a:t>8</a:t>
+              <a:t>9</a:t>
             </a:fld>
             <a:endParaRPr lang="en-US"/>
           </a:p>
@@ -5573,7 +5574,7 @@
           </a:solidFill>
           <a:ln w="12700">
             <a:solidFill>
-              <a:srgbClr val="6366F1"/>
+              <a:srgbClr val="49CC90"/>
             </a:solidFill>
             <a:prstDash val="solid"/>
           </a:ln>
@@ -10666,6 +10667,71 @@
 </file>
 
 <file path=ppt/slides/slide8.xml><?xml version="1.0" encoding="utf-8"?>
+<p:sld xmlns:a="http://schemas.openxmlformats.org/drawingml/2006/main" xmlns:r="http://schemas.openxmlformats.org/officeDocument/2006/relationships" xmlns:p="http://schemas.openxmlformats.org/presentationml/2006/main">
+  <p:cSld>
+    <p:spTree>
+      <p:nvGrpSpPr>
+        <p:cNvPr id="1" name=""/>
+        <p:cNvGrpSpPr/>
+        <p:nvPr/>
+      </p:nvGrpSpPr>
+      <p:grpSpPr>
+        <a:xfrm>
+          <a:off x="0" y="0"/>
+          <a:ext cx="0" cy="0"/>
+          <a:chOff x="0" y="0"/>
+          <a:chExt cx="0" cy="0"/>
+        </a:xfrm>
+      </p:grpSpPr>
+      <p:sp>
+        <p:nvSpPr>
+          <p:cNvPr id="2" name="CasetăText 1">
+            <a:extLst>
+              <a:ext uri="{FF2B5EF4-FFF2-40B4-BE49-F238E27FC236}">
+                <a16:creationId xmlns:a16="http://schemas.microsoft.com/office/drawing/2014/main" id="{6D0578A0-4B3B-40E2-292E-819ABAEB705E}"/>
+              </a:ext>
+            </a:extLst>
+          </p:cNvPr>
+          <p:cNvSpPr txBox="1"/>
+          <p:nvPr/>
+        </p:nvSpPr>
+        <p:spPr>
+          <a:xfrm>
+            <a:off x="3177540" y="1516380"/>
+            <a:ext cx="4008120" cy="369332"/>
+          </a:xfrm>
+          <a:prstGeom prst="rect">
+            <a:avLst/>
+          </a:prstGeom>
+          <a:noFill/>
+        </p:spPr>
+        <p:txBody>
+          <a:bodyPr wrap="square" rtlCol="0">
+            <a:spAutoFit/>
+          </a:bodyPr>
+          <a:lstStyle/>
+          <a:p>
+            <a:r>
+              <a:rPr lang="en-GB" dirty="0"/>
+              <a:t>DEMO</a:t>
+            </a:r>
+          </a:p>
+        </p:txBody>
+      </p:sp>
+    </p:spTree>
+    <p:extLst>
+      <p:ext uri="{BB962C8B-B14F-4D97-AF65-F5344CB8AC3E}">
+        <p14:creationId xmlns:p14="http://schemas.microsoft.com/office/powerpoint/2010/main" val="1292600944"/>
+      </p:ext>
+    </p:extLst>
+  </p:cSld>
+  <p:clrMapOvr>
+    <a:masterClrMapping/>
+  </p:clrMapOvr>
+</p:sld>
+</file>
+
+<file path=ppt/slides/slide9.xml><?xml version="1.0" encoding="utf-8"?>
 <p:sld xmlns:a="http://schemas.openxmlformats.org/drawingml/2006/main" xmlns:r="http://schemas.openxmlformats.org/officeDocument/2006/relationships" xmlns:p="http://schemas.openxmlformats.org/presentationml/2006/main">
   <p:cSld name="Slide 6">
     <p:bg>

</xml_diff>